<commit_message>
10/28 deck: say which sessions the whole-database table scores
Co-Authored-By: Claude Opus 5.5 <noreply@anthropic.com>
Claude-Session: https://claude.ai/code/session_017rMsJrfJb6LTfE8bFvgHeu
</commit_message>
<xml_diff>
--- a/docs/presentation/lab_meeting_10_28.pptx
+++ b/docs/presentation/lab_meeting_10_28.pptx
@@ -115,26 +115,26 @@
   <p:extLst>
     <p:ext uri="{521415D9-36F7-43E2-AB2F-B90AF26B5E84}">
       <p14:sectionLst xmlns:p14="http://schemas.microsoft.com/office/powerpoint/2010/main">
-        <p14:section name="Update" id="{24687d9c-2595-a3ab-f69c-b22a2e8ccccc}">
+        <p14:section name="Update" id="{7f0fdd2c-b91d-1b4a-ff99-ef2e7a93f817}">
           <p14:sldIdLst>
             <p14:sldId id="256"/>
             <p14:sldId id="257"/>
             <p14:sldId id="258"/>
           </p14:sldIdLst>
         </p14:section>
-        <p14:section name="Chewing" id="{9c26edca-27cf-f3fa-0ac7-58318dc17971}">
+        <p14:section name="Chewing" id="{f71bb009-f0d4-7fbf-9f43-fb9126307aae}">
           <p14:sldIdLst>
             <p14:sldId id="259"/>
             <p14:sldId id="260"/>
           </p14:sldIdLst>
         </p14:section>
-        <p14:section name="Analysis" id="{5b50e459-a642-24c4-c8af-d2f2009a7d72}">
+        <p14:section name="Analysis" id="{65760d44-0d92-8f4b-12c1-eeb16432749b}">
           <p14:sldIdLst>
             <p14:sldId id="261"/>
             <p14:sldId id="262"/>
           </p14:sldIdLst>
         </p14:section>
-        <p14:section name="Backup" id="{cbe1fe8c-88c4-1c64-f0c0-08740b4b765e}">
+        <p14:section name="Backup" id="{2b7d5f77-08b2-d4e6-7a54-dc5527f8213e}">
           <p14:sldIdLst>
             <p14:sldId id="263"/>
             <p14:sldId id="264"/>
@@ -2461,7 +2461,7 @@
           </p:nvPr>
         </p:nvGraphicFramePr>
         <p:xfrm>
-          <a:off x="411480" y="1005840"/>
+          <a:off x="411480" y="1325880"/>
           <a:ext cx="4206240" cy="914400"/>
         </p:xfrm>
         <a:graphic>
@@ -4246,6 +4246,42 @@
         </p:nvSpPr>
         <p:spPr>
           <a:xfrm>
+            <a:off x="411480" y="914400"/>
+            <a:ext cx="4206240" cy="365760"/>
+          </a:xfrm>
+          <a:prstGeom prst="rect">
+            <a:avLst/>
+          </a:prstGeom>
+          <a:noFill/>
+          <a:ln/>
+        </p:spPr>
+        <p:txBody>
+          <a:bodyPr wrap="square" lIns="0" tIns="0" rIns="0" bIns="0" rtlCol="0" anchor="t"/>
+          <a:lstStyle/>
+          <a:p>
+            <a:pPr indent="0" marL="0">
+              <a:buNone/>
+            </a:pPr>
+            <a:r>
+              <a:rPr lang="en-US" sz="1100" dirty="0">
+                <a:solidFill>
+                  <a:schemeClr val="tx2"/>
+                </a:solidFill>
+              </a:rPr>
+              <a:t>Scored: only the 8 sessions the model never trained on (the other 53 would be inflated)</a:t>
+            </a:r>
+            <a:endParaRPr lang="en-US" sz="1100" dirty="0"/>
+          </a:p>
+        </p:txBody>
+      </p:sp>
+      <p:sp>
+        <p:nvSpPr>
+          <p:cNvPr id="5" name="Text 2"/>
+          <p:cNvSpPr txBox="1"/>
+          <p:nvPr/>
+        </p:nvSpPr>
+        <p:spPr>
+          <a:xfrm>
             <a:off x="4937760" y="1051560"/>
             <a:ext cx="3840480" cy="3566160"/>
           </a:xfrm>
@@ -4272,7 +4308,7 @@
                   <a:schemeClr val="tx2"/>
                 </a:solidFill>
               </a:rPr>
-              <a:t>One command runs the model on all 61 recordings (about 1 s each)</a:t>
+              <a:t>One command ran the model on all 61 recordings in the database (about 1 s each)</a:t>
             </a:r>
             <a:endParaRPr lang="en-US" sz="1600" dirty="0"/>
           </a:p>

</xml_diff>

<commit_message>
10/28 deck: meal-type slide uses the per-session and paired figure
Co-Authored-By: Claude Opus 5.5 <noreply@anthropic.com>
Claude-Session: https://claude.ai/code/session_017rMsJrfJb6LTfE8bFvgHeu
</commit_message>
<xml_diff>
--- a/docs/presentation/lab_meeting_10_28.pptx
+++ b/docs/presentation/lab_meeting_10_28.pptx
@@ -115,26 +115,26 @@
   <p:extLst>
     <p:ext uri="{521415D9-36F7-43E2-AB2F-B90AF26B5E84}">
       <p14:sectionLst xmlns:p14="http://schemas.microsoft.com/office/powerpoint/2010/main">
-        <p14:section name="Update" id="{7f0fdd2c-b91d-1b4a-ff99-ef2e7a93f817}">
+        <p14:section name="Update" id="{faeb4cf1-03fb-80bc-40c0-1a4f89276db1}">
           <p14:sldIdLst>
             <p14:sldId id="256"/>
             <p14:sldId id="257"/>
             <p14:sldId id="258"/>
           </p14:sldIdLst>
         </p14:section>
-        <p14:section name="Chewing" id="{f71bb009-f0d4-7fbf-9f43-fb9126307aae}">
+        <p14:section name="Chewing" id="{c3b60e06-a6f1-7e88-d39e-1461879f1893}">
           <p14:sldIdLst>
             <p14:sldId id="259"/>
             <p14:sldId id="260"/>
           </p14:sldIdLst>
         </p14:section>
-        <p14:section name="Analysis" id="{65760d44-0d92-8f4b-12c1-eeb16432749b}">
+        <p14:section name="Analysis" id="{e3917f3a-f8f4-b34f-c738-b37a9ec05b75}">
           <p14:sldIdLst>
             <p14:sldId id="261"/>
             <p14:sldId id="262"/>
           </p14:sldIdLst>
         </p14:section>
-        <p14:section name="Backup" id="{2b7d5f77-08b2-d4e6-7a54-dc5527f8213e}">
+        <p14:section name="Backup" id="{c5d6874b-3929-99df-238b-746296079bf1}">
           <p14:sldIdLst>
             <p14:sldId id="263"/>
             <p14:sldId id="264"/>
@@ -984,7 +984,7 @@
           <a:p>
             <a:r>
               <a:rPr lang="en-US" dirty="0"/>
-              <a:t/>
+              <a:t>Right panel: 9 participants with a lunch and another meal; 7 of 9 lower at lunch, median difference -0.081, Wilcoxon p = 0.10 (too few people to be significant). The two that improved had their weakest session at the other meal. Snack shows 22 sessions: AIM125068's snack has no annotated eating, so no F1. Pooled: breakfast 0.882, dinner 0.884, lunch 0.829, snack 0.877.</a:t>
             </a:r>
             <a:endParaRPr lang="en-US" dirty="0"/>
           </a:p>
@@ -5090,1220 +5090,30 @@
           </a:p>
         </p:txBody>
       </p:sp>
-      <p:graphicFrame>
-        <p:nvGraphicFramePr>
-          <p:cNvPr id="7" name="Table 0"/>
-          <p:cNvGraphicFramePr>
-            <a:graphicFrameLocks noGrp="1"/>
-          </p:cNvGraphicFramePr>
-          <p:nvPr>
-            <p:extLst>
-              <p:ext uri="{D42A27DB-BD31-4B8C-83A1-F6EECF244321}">
-                <p14:modId xmlns:p14="http://schemas.microsoft.com/office/powerpoint/2010/main" val="1579011935"/>
-              </p:ext>
-            </p:extLst>
-          </p:nvPr>
-        </p:nvGraphicFramePr>
-        <p:xfrm>
-          <a:off x="411480" y="1097280"/>
-          <a:ext cx="4206240" cy="914400"/>
-        </p:xfrm>
-        <a:graphic>
-          <a:graphicData uri="http://schemas.openxmlformats.org/drawingml/2006/table">
-            <a:tbl>
-              <a:tblPr/>
-              <a:tblGrid>
-                <a:gridCol w="1463040"/>
-                <a:gridCol w="914400"/>
-                <a:gridCol w="914400"/>
-                <a:gridCol w="914400"/>
-              </a:tblGrid>
-              <a:tr h="411480">
-                <a:tc>
-                  <a:txBody>
-                    <a:bodyPr/>
-                    <a:lstStyle/>
-                    <a:p>
-                      <a:pPr indent="0" marL="0">
-                        <a:buNone/>
-                      </a:pPr>
-                      <a:r>
-                        <a:rPr lang="en-US" sz="1300" b="1" dirty="0">
-                          <a:solidFill>
-                            <a:srgbClr val="000000"/>
-                          </a:solidFill>
-                        </a:rPr>
-                        <a:t>Meal</a:t>
-                      </a:r>
-                      <a:endParaRPr lang="en-US" sz="1300" dirty="0"/>
-                    </a:p>
-                  </a:txBody>
-                  <a:tcPr marL="76200" marR="76200" marT="38100" marB="38100" anchor="ctr">
-                    <a:lnL w="9525" cap="flat" cmpd="sng" algn="ctr">
-                      <a:solidFill>
-                        <a:srgbClr val="A6A6A6"/>
-                      </a:solidFill>
-                      <a:prstDash val="solid"/>
-                      <a:round/>
-                      <a:headEnd type="none" w="med" len="med"/>
-                      <a:tailEnd type="none" w="med" len="med"/>
-                    </a:lnL>
-                    <a:lnR w="9525" cap="flat" cmpd="sng" algn="ctr">
-                      <a:solidFill>
-                        <a:srgbClr val="A6A6A6"/>
-                      </a:solidFill>
-                      <a:prstDash val="solid"/>
-                      <a:round/>
-                      <a:headEnd type="none" w="med" len="med"/>
-                      <a:tailEnd type="none" w="med" len="med"/>
-                    </a:lnR>
-                    <a:lnT w="9525" cap="flat" cmpd="sng" algn="ctr">
-                      <a:solidFill>
-                        <a:srgbClr val="A6A6A6"/>
-                      </a:solidFill>
-                      <a:prstDash val="solid"/>
-                      <a:round/>
-                      <a:headEnd type="none" w="med" len="med"/>
-                      <a:tailEnd type="none" w="med" len="med"/>
-                    </a:lnT>
-                    <a:lnB w="9525" cap="flat" cmpd="sng" algn="ctr">
-                      <a:solidFill>
-                        <a:srgbClr val="A6A6A6"/>
-                      </a:solidFill>
-                      <a:prstDash val="solid"/>
-                      <a:round/>
-                      <a:headEnd type="none" w="med" len="med"/>
-                      <a:tailEnd type="none" w="med" len="med"/>
-                    </a:lnB>
-                    <a:solidFill>
-                      <a:srgbClr val="F2F2F2"/>
-                    </a:solidFill>
-                  </a:tcPr>
-                </a:tc>
-                <a:tc>
-                  <a:txBody>
-                    <a:bodyPr/>
-                    <a:lstStyle/>
-                    <a:p>
-                      <a:pPr indent="0" marL="0">
-                        <a:buNone/>
-                      </a:pPr>
-                      <a:r>
-                        <a:rPr lang="en-US" sz="1300" b="1" dirty="0">
-                          <a:solidFill>
-                            <a:srgbClr val="000000"/>
-                          </a:solidFill>
-                        </a:rPr>
-                        <a:t>Sessions</a:t>
-                      </a:r>
-                      <a:endParaRPr lang="en-US" sz="1300" dirty="0"/>
-                    </a:p>
-                  </a:txBody>
-                  <a:tcPr marL="76200" marR="76200" marT="38100" marB="38100" anchor="ctr">
-                    <a:lnL w="9525" cap="flat" cmpd="sng" algn="ctr">
-                      <a:solidFill>
-                        <a:srgbClr val="A6A6A6"/>
-                      </a:solidFill>
-                      <a:prstDash val="solid"/>
-                      <a:round/>
-                      <a:headEnd type="none" w="med" len="med"/>
-                      <a:tailEnd type="none" w="med" len="med"/>
-                    </a:lnL>
-                    <a:lnR w="9525" cap="flat" cmpd="sng" algn="ctr">
-                      <a:solidFill>
-                        <a:srgbClr val="A6A6A6"/>
-                      </a:solidFill>
-                      <a:prstDash val="solid"/>
-                      <a:round/>
-                      <a:headEnd type="none" w="med" len="med"/>
-                      <a:tailEnd type="none" w="med" len="med"/>
-                    </a:lnR>
-                    <a:lnT w="9525" cap="flat" cmpd="sng" algn="ctr">
-                      <a:solidFill>
-                        <a:srgbClr val="A6A6A6"/>
-                      </a:solidFill>
-                      <a:prstDash val="solid"/>
-                      <a:round/>
-                      <a:headEnd type="none" w="med" len="med"/>
-                      <a:tailEnd type="none" w="med" len="med"/>
-                    </a:lnT>
-                    <a:lnB w="9525" cap="flat" cmpd="sng" algn="ctr">
-                      <a:solidFill>
-                        <a:srgbClr val="A6A6A6"/>
-                      </a:solidFill>
-                      <a:prstDash val="solid"/>
-                      <a:round/>
-                      <a:headEnd type="none" w="med" len="med"/>
-                      <a:tailEnd type="none" w="med" len="med"/>
-                    </a:lnB>
-                    <a:solidFill>
-                      <a:srgbClr val="F2F2F2"/>
-                    </a:solidFill>
-                  </a:tcPr>
-                </a:tc>
-                <a:tc>
-                  <a:txBody>
-                    <a:bodyPr/>
-                    <a:lstStyle/>
-                    <a:p>
-                      <a:pPr indent="0" marL="0">
-                        <a:buNone/>
-                      </a:pPr>
-                      <a:r>
-                        <a:rPr lang="en-US" sz="1300" b="1" dirty="0">
-                          <a:solidFill>
-                            <a:srgbClr val="000000"/>
-                          </a:solidFill>
-                        </a:rPr>
-                        <a:t>F1</a:t>
-                      </a:r>
-                      <a:endParaRPr lang="en-US" sz="1300" dirty="0"/>
-                    </a:p>
-                  </a:txBody>
-                  <a:tcPr marL="76200" marR="76200" marT="38100" marB="38100" anchor="ctr">
-                    <a:lnL w="9525" cap="flat" cmpd="sng" algn="ctr">
-                      <a:solidFill>
-                        <a:srgbClr val="A6A6A6"/>
-                      </a:solidFill>
-                      <a:prstDash val="solid"/>
-                      <a:round/>
-                      <a:headEnd type="none" w="med" len="med"/>
-                      <a:tailEnd type="none" w="med" len="med"/>
-                    </a:lnL>
-                    <a:lnR w="9525" cap="flat" cmpd="sng" algn="ctr">
-                      <a:solidFill>
-                        <a:srgbClr val="A6A6A6"/>
-                      </a:solidFill>
-                      <a:prstDash val="solid"/>
-                      <a:round/>
-                      <a:headEnd type="none" w="med" len="med"/>
-                      <a:tailEnd type="none" w="med" len="med"/>
-                    </a:lnR>
-                    <a:lnT w="9525" cap="flat" cmpd="sng" algn="ctr">
-                      <a:solidFill>
-                        <a:srgbClr val="A6A6A6"/>
-                      </a:solidFill>
-                      <a:prstDash val="solid"/>
-                      <a:round/>
-                      <a:headEnd type="none" w="med" len="med"/>
-                      <a:tailEnd type="none" w="med" len="med"/>
-                    </a:lnT>
-                    <a:lnB w="9525" cap="flat" cmpd="sng" algn="ctr">
-                      <a:solidFill>
-                        <a:srgbClr val="A6A6A6"/>
-                      </a:solidFill>
-                      <a:prstDash val="solid"/>
-                      <a:round/>
-                      <a:headEnd type="none" w="med" len="med"/>
-                      <a:tailEnd type="none" w="med" len="med"/>
-                    </a:lnB>
-                    <a:solidFill>
-                      <a:srgbClr val="F2F2F2"/>
-                    </a:solidFill>
-                  </a:tcPr>
-                </a:tc>
-                <a:tc>
-                  <a:txBody>
-                    <a:bodyPr/>
-                    <a:lstStyle/>
-                    <a:p>
-                      <a:pPr indent="0" marL="0">
-                        <a:buNone/>
-                      </a:pPr>
-                      <a:r>
-                        <a:rPr lang="en-US" sz="1300" b="1" dirty="0">
-                          <a:solidFill>
-                            <a:srgbClr val="000000"/>
-                          </a:solidFill>
-                        </a:rPr>
-                        <a:t>Recall</a:t>
-                      </a:r>
-                      <a:endParaRPr lang="en-US" sz="1300" dirty="0"/>
-                    </a:p>
-                  </a:txBody>
-                  <a:tcPr marL="76200" marR="76200" marT="38100" marB="38100" anchor="ctr">
-                    <a:lnL w="9525" cap="flat" cmpd="sng" algn="ctr">
-                      <a:solidFill>
-                        <a:srgbClr val="A6A6A6"/>
-                      </a:solidFill>
-                      <a:prstDash val="solid"/>
-                      <a:round/>
-                      <a:headEnd type="none" w="med" len="med"/>
-                      <a:tailEnd type="none" w="med" len="med"/>
-                    </a:lnL>
-                    <a:lnR w="9525" cap="flat" cmpd="sng" algn="ctr">
-                      <a:solidFill>
-                        <a:srgbClr val="A6A6A6"/>
-                      </a:solidFill>
-                      <a:prstDash val="solid"/>
-                      <a:round/>
-                      <a:headEnd type="none" w="med" len="med"/>
-                      <a:tailEnd type="none" w="med" len="med"/>
-                    </a:lnR>
-                    <a:lnT w="9525" cap="flat" cmpd="sng" algn="ctr">
-                      <a:solidFill>
-                        <a:srgbClr val="A6A6A6"/>
-                      </a:solidFill>
-                      <a:prstDash val="solid"/>
-                      <a:round/>
-                      <a:headEnd type="none" w="med" len="med"/>
-                      <a:tailEnd type="none" w="med" len="med"/>
-                    </a:lnT>
-                    <a:lnB w="9525" cap="flat" cmpd="sng" algn="ctr">
-                      <a:solidFill>
-                        <a:srgbClr val="A6A6A6"/>
-                      </a:solidFill>
-                      <a:prstDash val="solid"/>
-                      <a:round/>
-                      <a:headEnd type="none" w="med" len="med"/>
-                      <a:tailEnd type="none" w="med" len="med"/>
-                    </a:lnB>
-                    <a:solidFill>
-                      <a:srgbClr val="F2F2F2"/>
-                    </a:solidFill>
-                  </a:tcPr>
-                </a:tc>
-              </a:tr>
-              <a:tr h="411480">
-                <a:tc>
-                  <a:txBody>
-                    <a:bodyPr/>
-                    <a:lstStyle/>
-                    <a:p>
-                      <a:pPr indent="0" marL="0">
-                        <a:buNone/>
-                      </a:pPr>
-                      <a:r>
-                        <a:rPr lang="en-US" sz="1300" dirty="0">
-                          <a:solidFill>
-                            <a:srgbClr val="262626"/>
-                          </a:solidFill>
-                        </a:rPr>
-                        <a:t>Breakfast</a:t>
-                      </a:r>
-                      <a:endParaRPr lang="en-US" sz="1300" dirty="0"/>
-                    </a:p>
-                  </a:txBody>
-                  <a:tcPr marL="76200" marR="76200" marT="38100" marB="38100" anchor="ctr">
-                    <a:lnL w="9525" cap="flat" cmpd="sng" algn="ctr">
-                      <a:solidFill>
-                        <a:srgbClr val="A6A6A6"/>
-                      </a:solidFill>
-                      <a:prstDash val="solid"/>
-                      <a:round/>
-                      <a:headEnd type="none" w="med" len="med"/>
-                      <a:tailEnd type="none" w="med" len="med"/>
-                    </a:lnL>
-                    <a:lnR w="9525" cap="flat" cmpd="sng" algn="ctr">
-                      <a:solidFill>
-                        <a:srgbClr val="A6A6A6"/>
-                      </a:solidFill>
-                      <a:prstDash val="solid"/>
-                      <a:round/>
-                      <a:headEnd type="none" w="med" len="med"/>
-                      <a:tailEnd type="none" w="med" len="med"/>
-                    </a:lnR>
-                    <a:lnT w="9525" cap="flat" cmpd="sng" algn="ctr">
-                      <a:solidFill>
-                        <a:srgbClr val="A6A6A6"/>
-                      </a:solidFill>
-                      <a:prstDash val="solid"/>
-                      <a:round/>
-                      <a:headEnd type="none" w="med" len="med"/>
-                      <a:tailEnd type="none" w="med" len="med"/>
-                    </a:lnT>
-                    <a:lnB w="9525" cap="flat" cmpd="sng" algn="ctr">
-                      <a:solidFill>
-                        <a:srgbClr val="A6A6A6"/>
-                      </a:solidFill>
-                      <a:prstDash val="solid"/>
-                      <a:round/>
-                      <a:headEnd type="none" w="med" len="med"/>
-                      <a:tailEnd type="none" w="med" len="med"/>
-                    </a:lnB>
-                  </a:tcPr>
-                </a:tc>
-                <a:tc>
-                  <a:txBody>
-                    <a:bodyPr/>
-                    <a:lstStyle/>
-                    <a:p>
-                      <a:pPr indent="0" marL="0">
-                        <a:buNone/>
-                      </a:pPr>
-                      <a:r>
-                        <a:rPr lang="en-US" sz="1300" dirty="0">
-                          <a:solidFill>
-                            <a:srgbClr val="262626"/>
-                          </a:solidFill>
-                        </a:rPr>
-                        <a:t>8</a:t>
-                      </a:r>
-                      <a:endParaRPr lang="en-US" sz="1300" dirty="0"/>
-                    </a:p>
-                  </a:txBody>
-                  <a:tcPr marL="76200" marR="76200" marT="38100" marB="38100" anchor="ctr">
-                    <a:lnL w="9525" cap="flat" cmpd="sng" algn="ctr">
-                      <a:solidFill>
-                        <a:srgbClr val="A6A6A6"/>
-                      </a:solidFill>
-                      <a:prstDash val="solid"/>
-                      <a:round/>
-                      <a:headEnd type="none" w="med" len="med"/>
-                      <a:tailEnd type="none" w="med" len="med"/>
-                    </a:lnL>
-                    <a:lnR w="9525" cap="flat" cmpd="sng" algn="ctr">
-                      <a:solidFill>
-                        <a:srgbClr val="A6A6A6"/>
-                      </a:solidFill>
-                      <a:prstDash val="solid"/>
-                      <a:round/>
-                      <a:headEnd type="none" w="med" len="med"/>
-                      <a:tailEnd type="none" w="med" len="med"/>
-                    </a:lnR>
-                    <a:lnT w="9525" cap="flat" cmpd="sng" algn="ctr">
-                      <a:solidFill>
-                        <a:srgbClr val="A6A6A6"/>
-                      </a:solidFill>
-                      <a:prstDash val="solid"/>
-                      <a:round/>
-                      <a:headEnd type="none" w="med" len="med"/>
-                      <a:tailEnd type="none" w="med" len="med"/>
-                    </a:lnT>
-                    <a:lnB w="9525" cap="flat" cmpd="sng" algn="ctr">
-                      <a:solidFill>
-                        <a:srgbClr val="A6A6A6"/>
-                      </a:solidFill>
-                      <a:prstDash val="solid"/>
-                      <a:round/>
-                      <a:headEnd type="none" w="med" len="med"/>
-                      <a:tailEnd type="none" w="med" len="med"/>
-                    </a:lnB>
-                  </a:tcPr>
-                </a:tc>
-                <a:tc>
-                  <a:txBody>
-                    <a:bodyPr/>
-                    <a:lstStyle/>
-                    <a:p>
-                      <a:pPr indent="0" marL="0">
-                        <a:buNone/>
-                      </a:pPr>
-                      <a:r>
-                        <a:rPr lang="en-US" sz="1300" dirty="0">
-                          <a:solidFill>
-                            <a:srgbClr val="262626"/>
-                          </a:solidFill>
-                        </a:rPr>
-                        <a:t>0.882</a:t>
-                      </a:r>
-                      <a:endParaRPr lang="en-US" sz="1300" dirty="0"/>
-                    </a:p>
-                  </a:txBody>
-                  <a:tcPr marL="76200" marR="76200" marT="38100" marB="38100" anchor="ctr">
-                    <a:lnL w="9525" cap="flat" cmpd="sng" algn="ctr">
-                      <a:solidFill>
-                        <a:srgbClr val="A6A6A6"/>
-                      </a:solidFill>
-                      <a:prstDash val="solid"/>
-                      <a:round/>
-                      <a:headEnd type="none" w="med" len="med"/>
-                      <a:tailEnd type="none" w="med" len="med"/>
-                    </a:lnL>
-                    <a:lnR w="9525" cap="flat" cmpd="sng" algn="ctr">
-                      <a:solidFill>
-                        <a:srgbClr val="A6A6A6"/>
-                      </a:solidFill>
-                      <a:prstDash val="solid"/>
-                      <a:round/>
-                      <a:headEnd type="none" w="med" len="med"/>
-                      <a:tailEnd type="none" w="med" len="med"/>
-                    </a:lnR>
-                    <a:lnT w="9525" cap="flat" cmpd="sng" algn="ctr">
-                      <a:solidFill>
-                        <a:srgbClr val="A6A6A6"/>
-                      </a:solidFill>
-                      <a:prstDash val="solid"/>
-                      <a:round/>
-                      <a:headEnd type="none" w="med" len="med"/>
-                      <a:tailEnd type="none" w="med" len="med"/>
-                    </a:lnT>
-                    <a:lnB w="9525" cap="flat" cmpd="sng" algn="ctr">
-                      <a:solidFill>
-                        <a:srgbClr val="A6A6A6"/>
-                      </a:solidFill>
-                      <a:prstDash val="solid"/>
-                      <a:round/>
-                      <a:headEnd type="none" w="med" len="med"/>
-                      <a:tailEnd type="none" w="med" len="med"/>
-                    </a:lnB>
-                  </a:tcPr>
-                </a:tc>
-                <a:tc>
-                  <a:txBody>
-                    <a:bodyPr/>
-                    <a:lstStyle/>
-                    <a:p>
-                      <a:pPr indent="0" marL="0">
-                        <a:buNone/>
-                      </a:pPr>
-                      <a:r>
-                        <a:rPr lang="en-US" sz="1300" dirty="0">
-                          <a:solidFill>
-                            <a:srgbClr val="262626"/>
-                          </a:solidFill>
-                        </a:rPr>
-                        <a:t>0.909</a:t>
-                      </a:r>
-                      <a:endParaRPr lang="en-US" sz="1300" dirty="0"/>
-                    </a:p>
-                  </a:txBody>
-                  <a:tcPr marL="76200" marR="76200" marT="38100" marB="38100" anchor="ctr">
-                    <a:lnL w="9525" cap="flat" cmpd="sng" algn="ctr">
-                      <a:solidFill>
-                        <a:srgbClr val="A6A6A6"/>
-                      </a:solidFill>
-                      <a:prstDash val="solid"/>
-                      <a:round/>
-                      <a:headEnd type="none" w="med" len="med"/>
-                      <a:tailEnd type="none" w="med" len="med"/>
-                    </a:lnL>
-                    <a:lnR w="9525" cap="flat" cmpd="sng" algn="ctr">
-                      <a:solidFill>
-                        <a:srgbClr val="A6A6A6"/>
-                      </a:solidFill>
-                      <a:prstDash val="solid"/>
-                      <a:round/>
-                      <a:headEnd type="none" w="med" len="med"/>
-                      <a:tailEnd type="none" w="med" len="med"/>
-                    </a:lnR>
-                    <a:lnT w="9525" cap="flat" cmpd="sng" algn="ctr">
-                      <a:solidFill>
-                        <a:srgbClr val="A6A6A6"/>
-                      </a:solidFill>
-                      <a:prstDash val="solid"/>
-                      <a:round/>
-                      <a:headEnd type="none" w="med" len="med"/>
-                      <a:tailEnd type="none" w="med" len="med"/>
-                    </a:lnT>
-                    <a:lnB w="9525" cap="flat" cmpd="sng" algn="ctr">
-                      <a:solidFill>
-                        <a:srgbClr val="A6A6A6"/>
-                      </a:solidFill>
-                      <a:prstDash val="solid"/>
-                      <a:round/>
-                      <a:headEnd type="none" w="med" len="med"/>
-                      <a:tailEnd type="none" w="med" len="med"/>
-                    </a:lnB>
-                  </a:tcPr>
-                </a:tc>
-              </a:tr>
-              <a:tr h="411480">
-                <a:tc>
-                  <a:txBody>
-                    <a:bodyPr/>
-                    <a:lstStyle/>
-                    <a:p>
-                      <a:pPr indent="0" marL="0">
-                        <a:buNone/>
-                      </a:pPr>
-                      <a:r>
-                        <a:rPr lang="en-US" sz="1300" dirty="0">
-                          <a:solidFill>
-                            <a:srgbClr val="262626"/>
-                          </a:solidFill>
-                        </a:rPr>
-                        <a:t>Dinner</a:t>
-                      </a:r>
-                      <a:endParaRPr lang="en-US" sz="1300" dirty="0"/>
-                    </a:p>
-                  </a:txBody>
-                  <a:tcPr marL="76200" marR="76200" marT="38100" marB="38100" anchor="ctr">
-                    <a:lnL w="9525" cap="flat" cmpd="sng" algn="ctr">
-                      <a:solidFill>
-                        <a:srgbClr val="A6A6A6"/>
-                      </a:solidFill>
-                      <a:prstDash val="solid"/>
-                      <a:round/>
-                      <a:headEnd type="none" w="med" len="med"/>
-                      <a:tailEnd type="none" w="med" len="med"/>
-                    </a:lnL>
-                    <a:lnR w="9525" cap="flat" cmpd="sng" algn="ctr">
-                      <a:solidFill>
-                        <a:srgbClr val="A6A6A6"/>
-                      </a:solidFill>
-                      <a:prstDash val="solid"/>
-                      <a:round/>
-                      <a:headEnd type="none" w="med" len="med"/>
-                      <a:tailEnd type="none" w="med" len="med"/>
-                    </a:lnR>
-                    <a:lnT w="9525" cap="flat" cmpd="sng" algn="ctr">
-                      <a:solidFill>
-                        <a:srgbClr val="A6A6A6"/>
-                      </a:solidFill>
-                      <a:prstDash val="solid"/>
-                      <a:round/>
-                      <a:headEnd type="none" w="med" len="med"/>
-                      <a:tailEnd type="none" w="med" len="med"/>
-                    </a:lnT>
-                    <a:lnB w="9525" cap="flat" cmpd="sng" algn="ctr">
-                      <a:solidFill>
-                        <a:srgbClr val="A6A6A6"/>
-                      </a:solidFill>
-                      <a:prstDash val="solid"/>
-                      <a:round/>
-                      <a:headEnd type="none" w="med" len="med"/>
-                      <a:tailEnd type="none" w="med" len="med"/>
-                    </a:lnB>
-                  </a:tcPr>
-                </a:tc>
-                <a:tc>
-                  <a:txBody>
-                    <a:bodyPr/>
-                    <a:lstStyle/>
-                    <a:p>
-                      <a:pPr indent="0" marL="0">
-                        <a:buNone/>
-                      </a:pPr>
-                      <a:r>
-                        <a:rPr lang="en-US" sz="1300" dirty="0">
-                          <a:solidFill>
-                            <a:srgbClr val="262626"/>
-                          </a:solidFill>
-                        </a:rPr>
-                        <a:t>12</a:t>
-                      </a:r>
-                      <a:endParaRPr lang="en-US" sz="1300" dirty="0"/>
-                    </a:p>
-                  </a:txBody>
-                  <a:tcPr marL="76200" marR="76200" marT="38100" marB="38100" anchor="ctr">
-                    <a:lnL w="9525" cap="flat" cmpd="sng" algn="ctr">
-                      <a:solidFill>
-                        <a:srgbClr val="A6A6A6"/>
-                      </a:solidFill>
-                      <a:prstDash val="solid"/>
-                      <a:round/>
-                      <a:headEnd type="none" w="med" len="med"/>
-                      <a:tailEnd type="none" w="med" len="med"/>
-                    </a:lnL>
-                    <a:lnR w="9525" cap="flat" cmpd="sng" algn="ctr">
-                      <a:solidFill>
-                        <a:srgbClr val="A6A6A6"/>
-                      </a:solidFill>
-                      <a:prstDash val="solid"/>
-                      <a:round/>
-                      <a:headEnd type="none" w="med" len="med"/>
-                      <a:tailEnd type="none" w="med" len="med"/>
-                    </a:lnR>
-                    <a:lnT w="9525" cap="flat" cmpd="sng" algn="ctr">
-                      <a:solidFill>
-                        <a:srgbClr val="A6A6A6"/>
-                      </a:solidFill>
-                      <a:prstDash val="solid"/>
-                      <a:round/>
-                      <a:headEnd type="none" w="med" len="med"/>
-                      <a:tailEnd type="none" w="med" len="med"/>
-                    </a:lnT>
-                    <a:lnB w="9525" cap="flat" cmpd="sng" algn="ctr">
-                      <a:solidFill>
-                        <a:srgbClr val="A6A6A6"/>
-                      </a:solidFill>
-                      <a:prstDash val="solid"/>
-                      <a:round/>
-                      <a:headEnd type="none" w="med" len="med"/>
-                      <a:tailEnd type="none" w="med" len="med"/>
-                    </a:lnB>
-                  </a:tcPr>
-                </a:tc>
-                <a:tc>
-                  <a:txBody>
-                    <a:bodyPr/>
-                    <a:lstStyle/>
-                    <a:p>
-                      <a:pPr indent="0" marL="0">
-                        <a:buNone/>
-                      </a:pPr>
-                      <a:r>
-                        <a:rPr lang="en-US" sz="1300" dirty="0">
-                          <a:solidFill>
-                            <a:srgbClr val="262626"/>
-                          </a:solidFill>
-                        </a:rPr>
-                        <a:t>0.884</a:t>
-                      </a:r>
-                      <a:endParaRPr lang="en-US" sz="1300" dirty="0"/>
-                    </a:p>
-                  </a:txBody>
-                  <a:tcPr marL="76200" marR="76200" marT="38100" marB="38100" anchor="ctr">
-                    <a:lnL w="9525" cap="flat" cmpd="sng" algn="ctr">
-                      <a:solidFill>
-                        <a:srgbClr val="A6A6A6"/>
-                      </a:solidFill>
-                      <a:prstDash val="solid"/>
-                      <a:round/>
-                      <a:headEnd type="none" w="med" len="med"/>
-                      <a:tailEnd type="none" w="med" len="med"/>
-                    </a:lnL>
-                    <a:lnR w="9525" cap="flat" cmpd="sng" algn="ctr">
-                      <a:solidFill>
-                        <a:srgbClr val="A6A6A6"/>
-                      </a:solidFill>
-                      <a:prstDash val="solid"/>
-                      <a:round/>
-                      <a:headEnd type="none" w="med" len="med"/>
-                      <a:tailEnd type="none" w="med" len="med"/>
-                    </a:lnR>
-                    <a:lnT w="9525" cap="flat" cmpd="sng" algn="ctr">
-                      <a:solidFill>
-                        <a:srgbClr val="A6A6A6"/>
-                      </a:solidFill>
-                      <a:prstDash val="solid"/>
-                      <a:round/>
-                      <a:headEnd type="none" w="med" len="med"/>
-                      <a:tailEnd type="none" w="med" len="med"/>
-                    </a:lnT>
-                    <a:lnB w="9525" cap="flat" cmpd="sng" algn="ctr">
-                      <a:solidFill>
-                        <a:srgbClr val="A6A6A6"/>
-                      </a:solidFill>
-                      <a:prstDash val="solid"/>
-                      <a:round/>
-                      <a:headEnd type="none" w="med" len="med"/>
-                      <a:tailEnd type="none" w="med" len="med"/>
-                    </a:lnB>
-                  </a:tcPr>
-                </a:tc>
-                <a:tc>
-                  <a:txBody>
-                    <a:bodyPr/>
-                    <a:lstStyle/>
-                    <a:p>
-                      <a:pPr indent="0" marL="0">
-                        <a:buNone/>
-                      </a:pPr>
-                      <a:r>
-                        <a:rPr lang="en-US" sz="1300" dirty="0">
-                          <a:solidFill>
-                            <a:srgbClr val="262626"/>
-                          </a:solidFill>
-                        </a:rPr>
-                        <a:t>0.931</a:t>
-                      </a:r>
-                      <a:endParaRPr lang="en-US" sz="1300" dirty="0"/>
-                    </a:p>
-                  </a:txBody>
-                  <a:tcPr marL="76200" marR="76200" marT="38100" marB="38100" anchor="ctr">
-                    <a:lnL w="9525" cap="flat" cmpd="sng" algn="ctr">
-                      <a:solidFill>
-                        <a:srgbClr val="A6A6A6"/>
-                      </a:solidFill>
-                      <a:prstDash val="solid"/>
-                      <a:round/>
-                      <a:headEnd type="none" w="med" len="med"/>
-                      <a:tailEnd type="none" w="med" len="med"/>
-                    </a:lnL>
-                    <a:lnR w="9525" cap="flat" cmpd="sng" algn="ctr">
-                      <a:solidFill>
-                        <a:srgbClr val="A6A6A6"/>
-                      </a:solidFill>
-                      <a:prstDash val="solid"/>
-                      <a:round/>
-                      <a:headEnd type="none" w="med" len="med"/>
-                      <a:tailEnd type="none" w="med" len="med"/>
-                    </a:lnR>
-                    <a:lnT w="9525" cap="flat" cmpd="sng" algn="ctr">
-                      <a:solidFill>
-                        <a:srgbClr val="A6A6A6"/>
-                      </a:solidFill>
-                      <a:prstDash val="solid"/>
-                      <a:round/>
-                      <a:headEnd type="none" w="med" len="med"/>
-                      <a:tailEnd type="none" w="med" len="med"/>
-                    </a:lnT>
-                    <a:lnB w="9525" cap="flat" cmpd="sng" algn="ctr">
-                      <a:solidFill>
-                        <a:srgbClr val="A6A6A6"/>
-                      </a:solidFill>
-                      <a:prstDash val="solid"/>
-                      <a:round/>
-                      <a:headEnd type="none" w="med" len="med"/>
-                      <a:tailEnd type="none" w="med" len="med"/>
-                    </a:lnB>
-                  </a:tcPr>
-                </a:tc>
-              </a:tr>
-              <a:tr h="411480">
-                <a:tc>
-                  <a:txBody>
-                    <a:bodyPr/>
-                    <a:lstStyle/>
-                    <a:p>
-                      <a:pPr indent="0" marL="0">
-                        <a:buNone/>
-                      </a:pPr>
-                      <a:r>
-                        <a:rPr lang="en-US" sz="1300" b="1" dirty="0">
-                          <a:solidFill>
-                            <a:srgbClr val="262626"/>
-                          </a:solidFill>
-                        </a:rPr>
-                        <a:t>Lunch</a:t>
-                      </a:r>
-                      <a:endParaRPr lang="en-US" sz="1300" dirty="0"/>
-                    </a:p>
-                  </a:txBody>
-                  <a:tcPr marL="76200" marR="76200" marT="38100" marB="38100" anchor="ctr">
-                    <a:lnL w="9525" cap="flat" cmpd="sng" algn="ctr">
-                      <a:solidFill>
-                        <a:srgbClr val="A6A6A6"/>
-                      </a:solidFill>
-                      <a:prstDash val="solid"/>
-                      <a:round/>
-                      <a:headEnd type="none" w="med" len="med"/>
-                      <a:tailEnd type="none" w="med" len="med"/>
-                    </a:lnL>
-                    <a:lnR w="9525" cap="flat" cmpd="sng" algn="ctr">
-                      <a:solidFill>
-                        <a:srgbClr val="A6A6A6"/>
-                      </a:solidFill>
-                      <a:prstDash val="solid"/>
-                      <a:round/>
-                      <a:headEnd type="none" w="med" len="med"/>
-                      <a:tailEnd type="none" w="med" len="med"/>
-                    </a:lnR>
-                    <a:lnT w="9525" cap="flat" cmpd="sng" algn="ctr">
-                      <a:solidFill>
-                        <a:srgbClr val="A6A6A6"/>
-                      </a:solidFill>
-                      <a:prstDash val="solid"/>
-                      <a:round/>
-                      <a:headEnd type="none" w="med" len="med"/>
-                      <a:tailEnd type="none" w="med" len="med"/>
-                    </a:lnT>
-                    <a:lnB w="9525" cap="flat" cmpd="sng" algn="ctr">
-                      <a:solidFill>
-                        <a:srgbClr val="A6A6A6"/>
-                      </a:solidFill>
-                      <a:prstDash val="solid"/>
-                      <a:round/>
-                      <a:headEnd type="none" w="med" len="med"/>
-                      <a:tailEnd type="none" w="med" len="med"/>
-                    </a:lnB>
-                  </a:tcPr>
-                </a:tc>
-                <a:tc>
-                  <a:txBody>
-                    <a:bodyPr/>
-                    <a:lstStyle/>
-                    <a:p>
-                      <a:pPr indent="0" marL="0">
-                        <a:buNone/>
-                      </a:pPr>
-                      <a:r>
-                        <a:rPr lang="en-US" sz="1300" dirty="0">
-                          <a:solidFill>
-                            <a:srgbClr val="262626"/>
-                          </a:solidFill>
-                        </a:rPr>
-                        <a:t>18</a:t>
-                      </a:r>
-                      <a:endParaRPr lang="en-US" sz="1300" dirty="0"/>
-                    </a:p>
-                  </a:txBody>
-                  <a:tcPr marL="76200" marR="76200" marT="38100" marB="38100" anchor="ctr">
-                    <a:lnL w="9525" cap="flat" cmpd="sng" algn="ctr">
-                      <a:solidFill>
-                        <a:srgbClr val="A6A6A6"/>
-                      </a:solidFill>
-                      <a:prstDash val="solid"/>
-                      <a:round/>
-                      <a:headEnd type="none" w="med" len="med"/>
-                      <a:tailEnd type="none" w="med" len="med"/>
-                    </a:lnL>
-                    <a:lnR w="9525" cap="flat" cmpd="sng" algn="ctr">
-                      <a:solidFill>
-                        <a:srgbClr val="A6A6A6"/>
-                      </a:solidFill>
-                      <a:prstDash val="solid"/>
-                      <a:round/>
-                      <a:headEnd type="none" w="med" len="med"/>
-                      <a:tailEnd type="none" w="med" len="med"/>
-                    </a:lnR>
-                    <a:lnT w="9525" cap="flat" cmpd="sng" algn="ctr">
-                      <a:solidFill>
-                        <a:srgbClr val="A6A6A6"/>
-                      </a:solidFill>
-                      <a:prstDash val="solid"/>
-                      <a:round/>
-                      <a:headEnd type="none" w="med" len="med"/>
-                      <a:tailEnd type="none" w="med" len="med"/>
-                    </a:lnT>
-                    <a:lnB w="9525" cap="flat" cmpd="sng" algn="ctr">
-                      <a:solidFill>
-                        <a:srgbClr val="A6A6A6"/>
-                      </a:solidFill>
-                      <a:prstDash val="solid"/>
-                      <a:round/>
-                      <a:headEnd type="none" w="med" len="med"/>
-                      <a:tailEnd type="none" w="med" len="med"/>
-                    </a:lnB>
-                  </a:tcPr>
-                </a:tc>
-                <a:tc>
-                  <a:txBody>
-                    <a:bodyPr/>
-                    <a:lstStyle/>
-                    <a:p>
-                      <a:pPr indent="0" marL="0">
-                        <a:buNone/>
-                      </a:pPr>
-                      <a:r>
-                        <a:rPr lang="en-US" sz="1300" b="1" dirty="0">
-                          <a:solidFill>
-                            <a:srgbClr val="262626"/>
-                          </a:solidFill>
-                        </a:rPr>
-                        <a:t>0.829</a:t>
-                      </a:r>
-                      <a:endParaRPr lang="en-US" sz="1300" dirty="0"/>
-                    </a:p>
-                  </a:txBody>
-                  <a:tcPr marL="76200" marR="76200" marT="38100" marB="38100" anchor="ctr">
-                    <a:lnL w="9525" cap="flat" cmpd="sng" algn="ctr">
-                      <a:solidFill>
-                        <a:srgbClr val="A6A6A6"/>
-                      </a:solidFill>
-                      <a:prstDash val="solid"/>
-                      <a:round/>
-                      <a:headEnd type="none" w="med" len="med"/>
-                      <a:tailEnd type="none" w="med" len="med"/>
-                    </a:lnL>
-                    <a:lnR w="9525" cap="flat" cmpd="sng" algn="ctr">
-                      <a:solidFill>
-                        <a:srgbClr val="A6A6A6"/>
-                      </a:solidFill>
-                      <a:prstDash val="solid"/>
-                      <a:round/>
-                      <a:headEnd type="none" w="med" len="med"/>
-                      <a:tailEnd type="none" w="med" len="med"/>
-                    </a:lnR>
-                    <a:lnT w="9525" cap="flat" cmpd="sng" algn="ctr">
-                      <a:solidFill>
-                        <a:srgbClr val="A6A6A6"/>
-                      </a:solidFill>
-                      <a:prstDash val="solid"/>
-                      <a:round/>
-                      <a:headEnd type="none" w="med" len="med"/>
-                      <a:tailEnd type="none" w="med" len="med"/>
-                    </a:lnT>
-                    <a:lnB w="9525" cap="flat" cmpd="sng" algn="ctr">
-                      <a:solidFill>
-                        <a:srgbClr val="A6A6A6"/>
-                      </a:solidFill>
-                      <a:prstDash val="solid"/>
-                      <a:round/>
-                      <a:headEnd type="none" w="med" len="med"/>
-                      <a:tailEnd type="none" w="med" len="med"/>
-                    </a:lnB>
-                  </a:tcPr>
-                </a:tc>
-                <a:tc>
-                  <a:txBody>
-                    <a:bodyPr/>
-                    <a:lstStyle/>
-                    <a:p>
-                      <a:pPr indent="0" marL="0">
-                        <a:buNone/>
-                      </a:pPr>
-                      <a:r>
-                        <a:rPr lang="en-US" sz="1300" b="1" dirty="0">
-                          <a:solidFill>
-                            <a:srgbClr val="262626"/>
-                          </a:solidFill>
-                        </a:rPr>
-                        <a:t>0.819</a:t>
-                      </a:r>
-                      <a:endParaRPr lang="en-US" sz="1300" dirty="0"/>
-                    </a:p>
-                  </a:txBody>
-                  <a:tcPr marL="76200" marR="76200" marT="38100" marB="38100" anchor="ctr">
-                    <a:lnL w="9525" cap="flat" cmpd="sng" algn="ctr">
-                      <a:solidFill>
-                        <a:srgbClr val="A6A6A6"/>
-                      </a:solidFill>
-                      <a:prstDash val="solid"/>
-                      <a:round/>
-                      <a:headEnd type="none" w="med" len="med"/>
-                      <a:tailEnd type="none" w="med" len="med"/>
-                    </a:lnL>
-                    <a:lnR w="9525" cap="flat" cmpd="sng" algn="ctr">
-                      <a:solidFill>
-                        <a:srgbClr val="A6A6A6"/>
-                      </a:solidFill>
-                      <a:prstDash val="solid"/>
-                      <a:round/>
-                      <a:headEnd type="none" w="med" len="med"/>
-                      <a:tailEnd type="none" w="med" len="med"/>
-                    </a:lnR>
-                    <a:lnT w="9525" cap="flat" cmpd="sng" algn="ctr">
-                      <a:solidFill>
-                        <a:srgbClr val="A6A6A6"/>
-                      </a:solidFill>
-                      <a:prstDash val="solid"/>
-                      <a:round/>
-                      <a:headEnd type="none" w="med" len="med"/>
-                      <a:tailEnd type="none" w="med" len="med"/>
-                    </a:lnT>
-                    <a:lnB w="9525" cap="flat" cmpd="sng" algn="ctr">
-                      <a:solidFill>
-                        <a:srgbClr val="A6A6A6"/>
-                      </a:solidFill>
-                      <a:prstDash val="solid"/>
-                      <a:round/>
-                      <a:headEnd type="none" w="med" len="med"/>
-                      <a:tailEnd type="none" w="med" len="med"/>
-                    </a:lnB>
-                  </a:tcPr>
-                </a:tc>
-              </a:tr>
-              <a:tr h="411480">
-                <a:tc>
-                  <a:txBody>
-                    <a:bodyPr/>
-                    <a:lstStyle/>
-                    <a:p>
-                      <a:pPr indent="0" marL="0">
-                        <a:buNone/>
-                      </a:pPr>
-                      <a:r>
-                        <a:rPr lang="en-US" sz="1300" dirty="0">
-                          <a:solidFill>
-                            <a:srgbClr val="262626"/>
-                          </a:solidFill>
-                        </a:rPr>
-                        <a:t>Snack</a:t>
-                      </a:r>
-                      <a:endParaRPr lang="en-US" sz="1300" dirty="0"/>
-                    </a:p>
-                  </a:txBody>
-                  <a:tcPr marL="76200" marR="76200" marT="38100" marB="38100" anchor="ctr">
-                    <a:lnL w="9525" cap="flat" cmpd="sng" algn="ctr">
-                      <a:solidFill>
-                        <a:srgbClr val="A6A6A6"/>
-                      </a:solidFill>
-                      <a:prstDash val="solid"/>
-                      <a:round/>
-                      <a:headEnd type="none" w="med" len="med"/>
-                      <a:tailEnd type="none" w="med" len="med"/>
-                    </a:lnL>
-                    <a:lnR w="9525" cap="flat" cmpd="sng" algn="ctr">
-                      <a:solidFill>
-                        <a:srgbClr val="A6A6A6"/>
-                      </a:solidFill>
-                      <a:prstDash val="solid"/>
-                      <a:round/>
-                      <a:headEnd type="none" w="med" len="med"/>
-                      <a:tailEnd type="none" w="med" len="med"/>
-                    </a:lnR>
-                    <a:lnT w="9525" cap="flat" cmpd="sng" algn="ctr">
-                      <a:solidFill>
-                        <a:srgbClr val="A6A6A6"/>
-                      </a:solidFill>
-                      <a:prstDash val="solid"/>
-                      <a:round/>
-                      <a:headEnd type="none" w="med" len="med"/>
-                      <a:tailEnd type="none" w="med" len="med"/>
-                    </a:lnT>
-                    <a:lnB w="9525" cap="flat" cmpd="sng" algn="ctr">
-                      <a:solidFill>
-                        <a:srgbClr val="A6A6A6"/>
-                      </a:solidFill>
-                      <a:prstDash val="solid"/>
-                      <a:round/>
-                      <a:headEnd type="none" w="med" len="med"/>
-                      <a:tailEnd type="none" w="med" len="med"/>
-                    </a:lnB>
-                  </a:tcPr>
-                </a:tc>
-                <a:tc>
-                  <a:txBody>
-                    <a:bodyPr/>
-                    <a:lstStyle/>
-                    <a:p>
-                      <a:pPr indent="0" marL="0">
-                        <a:buNone/>
-                      </a:pPr>
-                      <a:r>
-                        <a:rPr lang="en-US" sz="1300" dirty="0">
-                          <a:solidFill>
-                            <a:srgbClr val="262626"/>
-                          </a:solidFill>
-                        </a:rPr>
-                        <a:t>23</a:t>
-                      </a:r>
-                      <a:endParaRPr lang="en-US" sz="1300" dirty="0"/>
-                    </a:p>
-                  </a:txBody>
-                  <a:tcPr marL="76200" marR="76200" marT="38100" marB="38100" anchor="ctr">
-                    <a:lnL w="9525" cap="flat" cmpd="sng" algn="ctr">
-                      <a:solidFill>
-                        <a:srgbClr val="A6A6A6"/>
-                      </a:solidFill>
-                      <a:prstDash val="solid"/>
-                      <a:round/>
-                      <a:headEnd type="none" w="med" len="med"/>
-                      <a:tailEnd type="none" w="med" len="med"/>
-                    </a:lnL>
-                    <a:lnR w="9525" cap="flat" cmpd="sng" algn="ctr">
-                      <a:solidFill>
-                        <a:srgbClr val="A6A6A6"/>
-                      </a:solidFill>
-                      <a:prstDash val="solid"/>
-                      <a:round/>
-                      <a:headEnd type="none" w="med" len="med"/>
-                      <a:tailEnd type="none" w="med" len="med"/>
-                    </a:lnR>
-                    <a:lnT w="9525" cap="flat" cmpd="sng" algn="ctr">
-                      <a:solidFill>
-                        <a:srgbClr val="A6A6A6"/>
-                      </a:solidFill>
-                      <a:prstDash val="solid"/>
-                      <a:round/>
-                      <a:headEnd type="none" w="med" len="med"/>
-                      <a:tailEnd type="none" w="med" len="med"/>
-                    </a:lnT>
-                    <a:lnB w="9525" cap="flat" cmpd="sng" algn="ctr">
-                      <a:solidFill>
-                        <a:srgbClr val="A6A6A6"/>
-                      </a:solidFill>
-                      <a:prstDash val="solid"/>
-                      <a:round/>
-                      <a:headEnd type="none" w="med" len="med"/>
-                      <a:tailEnd type="none" w="med" len="med"/>
-                    </a:lnB>
-                  </a:tcPr>
-                </a:tc>
-                <a:tc>
-                  <a:txBody>
-                    <a:bodyPr/>
-                    <a:lstStyle/>
-                    <a:p>
-                      <a:pPr indent="0" marL="0">
-                        <a:buNone/>
-                      </a:pPr>
-                      <a:r>
-                        <a:rPr lang="en-US" sz="1300" dirty="0">
-                          <a:solidFill>
-                            <a:srgbClr val="262626"/>
-                          </a:solidFill>
-                        </a:rPr>
-                        <a:t>0.877</a:t>
-                      </a:r>
-                      <a:endParaRPr lang="en-US" sz="1300" dirty="0"/>
-                    </a:p>
-                  </a:txBody>
-                  <a:tcPr marL="76200" marR="76200" marT="38100" marB="38100" anchor="ctr">
-                    <a:lnL w="9525" cap="flat" cmpd="sng" algn="ctr">
-                      <a:solidFill>
-                        <a:srgbClr val="A6A6A6"/>
-                      </a:solidFill>
-                      <a:prstDash val="solid"/>
-                      <a:round/>
-                      <a:headEnd type="none" w="med" len="med"/>
-                      <a:tailEnd type="none" w="med" len="med"/>
-                    </a:lnL>
-                    <a:lnR w="9525" cap="flat" cmpd="sng" algn="ctr">
-                      <a:solidFill>
-                        <a:srgbClr val="A6A6A6"/>
-                      </a:solidFill>
-                      <a:prstDash val="solid"/>
-                      <a:round/>
-                      <a:headEnd type="none" w="med" len="med"/>
-                      <a:tailEnd type="none" w="med" len="med"/>
-                    </a:lnR>
-                    <a:lnT w="9525" cap="flat" cmpd="sng" algn="ctr">
-                      <a:solidFill>
-                        <a:srgbClr val="A6A6A6"/>
-                      </a:solidFill>
-                      <a:prstDash val="solid"/>
-                      <a:round/>
-                      <a:headEnd type="none" w="med" len="med"/>
-                      <a:tailEnd type="none" w="med" len="med"/>
-                    </a:lnT>
-                    <a:lnB w="9525" cap="flat" cmpd="sng" algn="ctr">
-                      <a:solidFill>
-                        <a:srgbClr val="A6A6A6"/>
-                      </a:solidFill>
-                      <a:prstDash val="solid"/>
-                      <a:round/>
-                      <a:headEnd type="none" w="med" len="med"/>
-                      <a:tailEnd type="none" w="med" len="med"/>
-                    </a:lnB>
-                  </a:tcPr>
-                </a:tc>
-                <a:tc>
-                  <a:txBody>
-                    <a:bodyPr/>
-                    <a:lstStyle/>
-                    <a:p>
-                      <a:pPr indent="0" marL="0">
-                        <a:buNone/>
-                      </a:pPr>
-                      <a:r>
-                        <a:rPr lang="en-US" sz="1300" dirty="0">
-                          <a:solidFill>
-                            <a:srgbClr val="262626"/>
-                          </a:solidFill>
-                        </a:rPr>
-                        <a:t>0.891</a:t>
-                      </a:r>
-                      <a:endParaRPr lang="en-US" sz="1300" dirty="0"/>
-                    </a:p>
-                  </a:txBody>
-                  <a:tcPr marL="76200" marR="76200" marT="38100" marB="38100" anchor="ctr">
-                    <a:lnL w="9525" cap="flat" cmpd="sng" algn="ctr">
-                      <a:solidFill>
-                        <a:srgbClr val="A6A6A6"/>
-                      </a:solidFill>
-                      <a:prstDash val="solid"/>
-                      <a:round/>
-                      <a:headEnd type="none" w="med" len="med"/>
-                      <a:tailEnd type="none" w="med" len="med"/>
-                    </a:lnL>
-                    <a:lnR w="9525" cap="flat" cmpd="sng" algn="ctr">
-                      <a:solidFill>
-                        <a:srgbClr val="A6A6A6"/>
-                      </a:solidFill>
-                      <a:prstDash val="solid"/>
-                      <a:round/>
-                      <a:headEnd type="none" w="med" len="med"/>
-                      <a:tailEnd type="none" w="med" len="med"/>
-                    </a:lnR>
-                    <a:lnT w="9525" cap="flat" cmpd="sng" algn="ctr">
-                      <a:solidFill>
-                        <a:srgbClr val="A6A6A6"/>
-                      </a:solidFill>
-                      <a:prstDash val="solid"/>
-                      <a:round/>
-                      <a:headEnd type="none" w="med" len="med"/>
-                      <a:tailEnd type="none" w="med" len="med"/>
-                    </a:lnT>
-                    <a:lnB w="9525" cap="flat" cmpd="sng" algn="ctr">
-                      <a:solidFill>
-                        <a:srgbClr val="A6A6A6"/>
-                      </a:solidFill>
-                      <a:prstDash val="solid"/>
-                      <a:round/>
-                      <a:headEnd type="none" w="med" len="med"/>
-                      <a:tailEnd type="none" w="med" len="med"/>
-                    </a:lnB>
-                  </a:tcPr>
-                </a:tc>
-              </a:tr>
-            </a:tbl>
-          </a:graphicData>
-        </a:graphic>
-      </p:graphicFrame>
+      <p:pic>
+        <p:nvPicPr>
+          <p:cNvPr id="3" name="Image 0" descr="F1 per session by meal type, and lunch versus the same participant's other meal">    </p:cNvPr>
+          <p:cNvPicPr>
+            <a:picLocks noChangeAspect="1"/>
+          </p:cNvPicPr>
+          <p:nvPr/>
+        </p:nvPicPr>
+        <p:blipFill>
+          <a:blip r:embed="rId1"/>
+          <a:stretch>
+            <a:fillRect/>
+          </a:stretch>
+        </p:blipFill>
+        <p:spPr>
+          <a:xfrm>
+            <a:off x="731520" y="868680"/>
+            <a:ext cx="7680960" cy="3072384"/>
+          </a:xfrm>
+          <a:prstGeom prst="rect">
+            <a:avLst/>
+          </a:prstGeom>
+        </p:spPr>
+      </p:pic>
       <p:sp>
         <p:nvSpPr>
           <p:cNvPr id="4" name="Text 1"/>
@@ -6312,8 +5122,8 @@
         </p:nvSpPr>
         <p:spPr>
           <a:xfrm>
-            <a:off x="4937760" y="1051560"/>
-            <a:ext cx="3840480" cy="3566160"/>
+            <a:off x="731520" y="4069080"/>
+            <a:ext cx="7680960" cy="777240"/>
           </a:xfrm>
           <a:prstGeom prst="rect">
             <a:avLst/>
@@ -6333,14 +5143,14 @@
               <a:buChar char="•"/>
             </a:pPr>
             <a:r>
-              <a:rPr lang="en-US" sz="1600" dirty="0">
+              <a:rPr lang="en-US" sz="1400" dirty="0">
                 <a:solidFill>
                   <a:schemeClr val="tx2"/>
                 </a:solidFill>
               </a:rPr>
-              <a:t>Lunches score lower than other meals: median session F1 0.815 vs 0.890 (p = 0.009)</a:t>
-            </a:r>
-            <a:endParaRPr lang="en-US" sz="1600" dirty="0"/>
+              <a:t>Lunches score lower: median F1 0.815 vs 0.890 for other meals (p = 0.009); the drop is mostly missed eating (recall 0.82)</a:t>
+            </a:r>
+            <a:endParaRPr lang="en-US" sz="1400" dirty="0"/>
           </a:p>
           <a:p>
             <a:pPr marL="342900" indent="-342900">
@@ -6351,50 +5161,14 @@
               <a:buChar char="•"/>
             </a:pPr>
             <a:r>
-              <a:rPr lang="en-US" sz="1600" dirty="0">
-                <a:solidFill>
-                  <a:schemeClr val="tx2"/>
-                </a:solidFill>
-              </a:rPr>
-              <a:t>The drop is mostly recall: eating at lunch gets missed more</a:t>
-            </a:r>
-            <a:endParaRPr lang="en-US" sz="1600" dirty="0"/>
-          </a:p>
-          <a:p>
-            <a:pPr marL="342900" indent="-342900">
-              <a:spcAft>
-                <a:spcPts val="800"/>
-              </a:spcAft>
-              <a:buSzPct val="100000"/>
-              <a:buChar char="•"/>
-            </a:pPr>
-            <a:r>
-              <a:rPr lang="en-US" sz="1600" dirty="0">
-                <a:solidFill>
-                  <a:schemeClr val="tx2"/>
-                </a:solidFill>
-              </a:rPr>
-              <a:t>Same participants: 7 of 9 did worse at lunch (p = 0.10, too few people)</a:t>
-            </a:r>
-            <a:endParaRPr lang="en-US" sz="1600" dirty="0"/>
-          </a:p>
-          <a:p>
-            <a:pPr marL="342900" indent="-342900">
-              <a:spcAft>
-                <a:spcPts val="800"/>
-              </a:spcAft>
-              <a:buSzPct val="100000"/>
-              <a:buChar char="•"/>
-            </a:pPr>
-            <a:r>
-              <a:rPr lang="en-US" sz="1600" dirty="0">
+              <a:rPr lang="en-US" sz="1400" dirty="0">
                 <a:solidFill>
                   <a:schemeClr val="tx2"/>
                 </a:solidFill>
               </a:rPr>
               <a:t>Some lunches were solo, so this is not yet a group-eating result; asked Siavash where session setting is recorded</a:t>
             </a:r>
-            <a:endParaRPr lang="en-US" sz="1600" dirty="0"/>
+            <a:endParaRPr lang="en-US" sz="1400" dirty="0"/>
           </a:p>
         </p:txBody>
       </p:sp>

</xml_diff>